<commit_message>
docs & output files
</commit_message>
<xml_diff>
--- a/Documents/SalesAnalysis_FrameWork.pptx
+++ b/Documents/SalesAnalysis_FrameWork.pptx
@@ -126,7 +126,7 @@
 <file path=ppt/revisionInfo.xml><?xml version="1.0" encoding="utf-8"?>
 <p1510:revInfo xmlns:a="http://schemas.openxmlformats.org/drawingml/2006/main" xmlns:r="http://schemas.openxmlformats.org/officeDocument/2006/relationships" xmlns:p1510="http://schemas.microsoft.com/office/powerpoint/2015/10/main">
   <p1510:revLst>
-    <p1510:client id="{2B2209F0-BDE7-45E7-803F-D0546AA3A300}" v="1" dt="2026-03-06T11:18:55.725"/>
+    <p1510:client id="{2B2209F0-BDE7-45E7-803F-D0546AA3A300}" v="3" dt="2026-03-06T12:00:53.899"/>
     <p1510:client id="{912109E2-55E3-4DE1-90FF-B564DE695E44}" v="72" dt="2026-03-06T07:37:43.733"/>
     <p1510:client id="{AD710007-99E5-4D0E-87C7-B7CFF48C7ABB}" v="44" dt="2026-03-06T02:49:07.537"/>
   </p1510:revLst>
@@ -138,12 +138,12 @@
   <pc:docChgLst>
     <pc:chgData name="bharath u" userId="c58c4ed255503daa" providerId="LiveId" clId="{5F7C9199-54C3-4129-A0AC-0FF32D78B41F}"/>
     <pc:docChg chg="undo custSel addSld delSld modSld sldOrd">
-      <pc:chgData name="bharath u" userId="c58c4ed255503daa" providerId="LiveId" clId="{5F7C9199-54C3-4129-A0AC-0FF32D78B41F}" dt="2026-03-06T11:18:57.241" v="801" actId="20577"/>
+      <pc:chgData name="bharath u" userId="c58c4ed255503daa" providerId="LiveId" clId="{5F7C9199-54C3-4129-A0AC-0FF32D78B41F}" dt="2026-03-06T12:00:53.899" v="805" actId="20577"/>
       <pc:docMkLst>
         <pc:docMk/>
       </pc:docMkLst>
       <pc:sldChg chg="addSp modSp mod addAnim">
-        <pc:chgData name="bharath u" userId="c58c4ed255503daa" providerId="LiveId" clId="{5F7C9199-54C3-4129-A0AC-0FF32D78B41F}" dt="2026-03-06T05:42:23.475" v="152" actId="113"/>
+        <pc:chgData name="bharath u" userId="c58c4ed255503daa" providerId="LiveId" clId="{5F7C9199-54C3-4129-A0AC-0FF32D78B41F}" dt="2026-03-06T12:00:53.899" v="805" actId="20577"/>
         <pc:sldMkLst>
           <pc:docMk/>
           <pc:sldMk cId="868654895" sldId="256"/>
@@ -157,7 +157,7 @@
           </ac:spMkLst>
         </pc:spChg>
         <pc:spChg chg="mod">
-          <ac:chgData name="bharath u" userId="c58c4ed255503daa" providerId="LiveId" clId="{5F7C9199-54C3-4129-A0AC-0FF32D78B41F}" dt="2026-03-06T05:42:23.475" v="152" actId="113"/>
+          <ac:chgData name="bharath u" userId="c58c4ed255503daa" providerId="LiveId" clId="{5F7C9199-54C3-4129-A0AC-0FF32D78B41F}" dt="2026-03-06T12:00:53.899" v="805" actId="20577"/>
           <ac:spMkLst>
             <pc:docMk/>
             <pc:sldMk cId="868654895" sldId="256"/>
@@ -567,7 +567,7 @@
         </pc:spChg>
       </pc:sldChg>
       <pc:sldChg chg="addSp delSp modSp mod">
-        <pc:chgData name="bharath u" userId="c58c4ed255503daa" providerId="LiveId" clId="{5F7C9199-54C3-4129-A0AC-0FF32D78B41F}" dt="2026-03-06T11:18:46.031" v="799" actId="478"/>
+        <pc:chgData name="bharath u" userId="c58c4ed255503daa" providerId="LiveId" clId="{5F7C9199-54C3-4129-A0AC-0FF32D78B41F}" dt="2026-03-06T12:00:49.007" v="804" actId="1076"/>
         <pc:sldMkLst>
           <pc:docMk/>
           <pc:sldMk cId="1779968709" sldId="266"/>
@@ -588,6 +588,14 @@
             <ac:spMk id="3" creationId="{9CE482F7-AE1E-E324-85E5-EB48925FA79E}"/>
           </ac:spMkLst>
         </pc:spChg>
+        <pc:graphicFrameChg chg="add mod">
+          <ac:chgData name="bharath u" userId="c58c4ed255503daa" providerId="LiveId" clId="{5F7C9199-54C3-4129-A0AC-0FF32D78B41F}" dt="2026-03-06T12:00:49.007" v="804" actId="1076"/>
+          <ac:graphicFrameMkLst>
+            <pc:docMk/>
+            <pc:sldMk cId="1779968709" sldId="266"/>
+            <ac:graphicFrameMk id="4" creationId="{37314922-FF94-54A3-F8BD-E972CA4C0976}"/>
+          </ac:graphicFrameMkLst>
+        </pc:graphicFrameChg>
         <pc:graphicFrameChg chg="del">
           <ac:chgData name="bharath u" userId="c58c4ed255503daa" providerId="LiveId" clId="{5F7C9199-54C3-4129-A0AC-0FF32D78B41F}" dt="2026-03-06T07:15:37.482" v="789" actId="478"/>
           <ac:graphicFrameMkLst>
@@ -597,7 +605,7 @@
           </ac:graphicFrameMkLst>
         </pc:graphicFrameChg>
         <pc:graphicFrameChg chg="add del mod">
-          <ac:chgData name="bharath u" userId="c58c4ed255503daa" providerId="LiveId" clId="{5F7C9199-54C3-4129-A0AC-0FF32D78B41F}" dt="2026-03-06T11:18:46.031" v="799" actId="478"/>
+          <ac:chgData name="bharath u" userId="c58c4ed255503daa" providerId="LiveId" clId="{5F7C9199-54C3-4129-A0AC-0FF32D78B41F}" dt="2026-03-06T12:00:23.748" v="802" actId="478"/>
           <ac:graphicFrameMkLst>
             <pc:docMk/>
             <pc:sldMk cId="1779968709" sldId="266"/>
@@ -5694,8 +5702,21 @@
                   <a:srgbClr val="FFFFFF"/>
                 </a:solidFill>
               </a:rPr>
-              <a:t>Automated, scalable processing of web sales and search data</a:t>
-            </a:r>
+              <a:t>Automated, scalable processing of web sales and </a:t>
+            </a:r>
+            <a:r>
+              <a:rPr lang="en-US" b="1">
+                <a:solidFill>
+                  <a:srgbClr val="FFFFFF"/>
+                </a:solidFill>
+              </a:rPr>
+              <a:t>search data </a:t>
+            </a:r>
+            <a:endParaRPr lang="en-US" b="1" dirty="0">
+              <a:solidFill>
+                <a:srgbClr val="FFFFFF"/>
+              </a:solidFill>
+            </a:endParaRPr>
           </a:p>
         </p:txBody>
       </p:sp>
@@ -8381,10 +8402,10 @@
       </p:graphicFrame>
       <p:graphicFrame>
         <p:nvGraphicFramePr>
-          <p:cNvPr id="7" name="Object 6">
+          <p:cNvPr id="4" name="Object 3">
             <a:extLst>
               <a:ext uri="{FF2B5EF4-FFF2-40B4-BE49-F238E27FC236}">
-                <a16:creationId xmlns:a16="http://schemas.microsoft.com/office/drawing/2014/main" id="{F0245E00-F4DC-89EA-DB65-06933D3ABFA2}"/>
+                <a16:creationId xmlns:a16="http://schemas.microsoft.com/office/drawing/2014/main" id="{37314922-FF94-54A3-F8BD-E972CA4C0976}"/>
               </a:ext>
             </a:extLst>
           </p:cNvPr>
@@ -8394,13 +8415,13 @@
           <p:nvPr>
             <p:extLst>
               <p:ext uri="{D42A27DB-BD31-4B8C-83A1-F6EECF244321}">
-                <p14:modId xmlns:p14="http://schemas.microsoft.com/office/powerpoint/2010/main" val="3582001568"/>
+                <p14:modId xmlns:p14="http://schemas.microsoft.com/office/powerpoint/2010/main" val="535323685"/>
               </p:ext>
             </p:extLst>
           </p:nvPr>
         </p:nvGraphicFramePr>
         <p:xfrm>
-          <a:off x="1800225" y="3710517"/>
+          <a:off x="1800225" y="3642784"/>
           <a:ext cx="914400" cy="806450"/>
         </p:xfrm>
         <a:graphic>
@@ -8416,10 +8437,10 @@
                   <p:embed/>
                   <p:pic>
                     <p:nvPicPr>
-                      <p:cNvPr id="7" name="Object 6">
+                      <p:cNvPr id="4" name="Object 3">
                         <a:extLst>
                           <a:ext uri="{FF2B5EF4-FFF2-40B4-BE49-F238E27FC236}">
-                            <a16:creationId xmlns:a16="http://schemas.microsoft.com/office/drawing/2014/main" id="{F0245E00-F4DC-89EA-DB65-06933D3ABFA2}"/>
+                            <a16:creationId xmlns:a16="http://schemas.microsoft.com/office/drawing/2014/main" id="{37314922-FF94-54A3-F8BD-E972CA4C0976}"/>
                           </a:ext>
                         </a:extLst>
                       </p:cNvPr>
@@ -8434,7 +8455,7 @@
                     </p:blipFill>
                     <p:spPr>
                       <a:xfrm>
-                        <a:off x="1800225" y="3710517"/>
+                        <a:off x="1800225" y="3642784"/>
                         <a:ext cx="914400" cy="806450"/>
                       </a:xfrm>
                       <a:prstGeom prst="rect">

</xml_diff>